<commit_message>
Declutter prototyping slide, add Hall of Shame sources and rehearsal kit
- prototyping slide: drop status pills, keep struck request and stamp;
  status guidance moves to speaker notes
- notebook/hall-of-shame-sources.md: primary and secondary sources and
  dates for the five cases, with lessons marked INFERRED and open checks
- docs/REHEARSAL.md and scripts/new-rehearsal.sh: dated capture folder
  (gitignored) with per-motion sheets and a timing table
- slides/Build-the-Right-Thing.pdf: fallback export if brand fonts are
  missing on the presenting machine
- remove stale Build-the-Right-Thing-v2.pptx snapshot

Co-Authored-By: Claude Sonnet 5.5 <noreply@anthropic.com>
</commit_message>
<xml_diff>
--- a/slides/Build-the-Right-Thing.pptx
+++ b/slides/Build-the-Right-Thing.pptx
@@ -1755,7 +1755,7 @@
           <a:p>
             <a:r>
               <a:rPr lang="en-US" dirty="0"/>
-              <a:t>The question is the smallest, cheapest test that surfaces the most brutal truth. Compare a conversation, a storyboard or wireframe test, an interaction, and a build. Recommend the tiniest act of discovery that can answer it. Prototypes built in advance are implementation evidence only. The participant test stays NOT RUN until a person actually runs it. If you did not build one, say NOT BUILT.</a:t>
+              <a:t>The question is the smallest, cheapest test that surfaces the most brutal truth. Compare a conversation, a storyboard or wireframe test, an interaction, and a build. Recommend the tiniest act of discovery that can answer it. Status, if asked: prototypes built in advance are implementation evidence only. The participant test is NOT RUN until a person actually runs it. If you did not build one, say NOT BUILT.</a:t>
             </a:r>
             <a:endParaRPr lang="en-US" dirty="0"/>
           </a:p>
@@ -1931,7 +1931,7 @@
           <a:p>
             <a:r>
               <a:rPr lang="en-US" dirty="0"/>
-              <a:t>Spoken opening. Five cases, one line each, then leave the slide. Source URLs and dates for each case: [ATTACH BEFORE SHOWTIME]. Do not research cases on stage. Lessons: Relay.app, differentiation must keep being earned. Humane AI Pin, novelty does not equal customer value. Google Gemini image generation, optimizing one thing can break another. Air Canada chatbot, automation does not outsource accountability. Zillow Offers, model performance does not guarantee business viability.</a:t>
+              <a:t>Spoken opening. Five cases, one line each, then leave the slide. Do not research cases on stage. Sources are in notebook/hall-of-shame-sources.md. Facts: Relay.app shut down in 2026 (relay.app). Humane AI Pin discontinued Feb 2025 after HP bought assets for $116M (TechCrunch, Feb 18 2025). Google paused Gemini image generation of people, Feb 23 2024 (blog.google). Air Canada held liable for its chatbot, Moffatt v. Air Canada, 2024 BCCRT 149. Zillow wound down Zillow Offers, Q3 2021 shareholder letter, Nov 2 2021. The one-line lessons are Dean's interpretation (INFERRED), not claims the sources make.</a:t>
             </a:r>
             <a:endParaRPr lang="en-US" dirty="0"/>
           </a:p>
@@ -10677,11 +10677,11 @@
         <p:spPr>
           <a:xfrm>
             <a:off x="6629400" y="1005840"/>
-            <a:ext cx="4663440" cy="3108960"/>
+            <a:ext cx="4663440" cy="4663440"/>
           </a:xfrm>
           <a:prstGeom prst="roundRect">
             <a:avLst>
-              <a:gd name="adj" fmla="val 5294"/>
+              <a:gd name="adj" fmla="val 3529"/>
             </a:avLst>
           </a:prstGeom>
           <a:solidFill>
@@ -10703,8 +10703,8 @@
         </p:nvSpPr>
         <p:spPr>
           <a:xfrm>
-            <a:off x="6995160" y="1371600"/>
-            <a:ext cx="3931920" cy="1188720"/>
+            <a:off x="6995160" y="1463040"/>
+            <a:ext cx="3931920" cy="1463040"/>
           </a:xfrm>
           <a:prstGeom prst="rect">
             <a:avLst/>
@@ -10720,7 +10720,7 @@
               <a:buNone/>
             </a:pPr>
             <a:r>
-              <a:rPr lang="en-US" sz="2600" strike="sngStrike" dirty="0">
+              <a:rPr lang="en-US" sz="3000" strike="sngStrike" dirty="0">
                 <a:solidFill>
                   <a:srgbClr val="7A7A7A"/>
                 </a:solidFill>
@@ -10730,7 +10730,7 @@
               </a:rPr>
               <a:t>Build an AI predictive-maintenance dashboard.</a:t>
             </a:r>
-            <a:endParaRPr lang="en-US" sz="2600" dirty="0"/>
+            <a:endParaRPr lang="en-US" sz="3000" dirty="0"/>
           </a:p>
         </p:txBody>
       </p:sp>
@@ -10742,12 +10742,12 @@
         </p:nvSpPr>
         <p:spPr>
           <a:xfrm rot="21300000">
-            <a:off x="7086600" y="2560320"/>
-            <a:ext cx="3749040" cy="1097280"/>
+            <a:off x="6995160" y="3291840"/>
+            <a:ext cx="3931920" cy="1371600"/>
           </a:xfrm>
           <a:prstGeom prst="roundRect">
             <a:avLst>
-              <a:gd name="adj" fmla="val 8333"/>
+              <a:gd name="adj" fmla="val 6667"/>
             </a:avLst>
           </a:prstGeom>
           <a:ln w="63500">
@@ -10764,7 +10764,7 @@
               <a:buNone/>
             </a:pPr>
             <a:r>
-              <a:rPr lang="en-US" sz="3000" dirty="0">
+              <a:rPr lang="en-US" sz="3400" dirty="0">
                 <a:solidFill>
                   <a:srgbClr val="00C765"/>
                 </a:solidFill>
@@ -10774,132 +10774,7 @@
               </a:rPr>
               <a:t>TINIEST ACT WINS</a:t>
             </a:r>
-            <a:endParaRPr lang="en-US" sz="3000" dirty="0"/>
-          </a:p>
-        </p:txBody>
-      </p:sp>
-      <p:sp>
-        <p:nvSpPr>
-          <p:cNvPr id="11" name="Pill BUILT: IMPLEMENTATION CHECK ONLY"/>
-          <p:cNvSpPr/>
-          <p:nvPr/>
-        </p:nvSpPr>
-        <p:spPr>
-          <a:xfrm>
-            <a:off x="6629400" y="4297680"/>
-            <a:ext cx="4617720" cy="329184"/>
-          </a:xfrm>
-          <a:prstGeom prst="roundRect">
-            <a:avLst>
-              <a:gd name="adj" fmla="val 50000"/>
-            </a:avLst>
-          </a:prstGeom>
-          <a:solidFill>
-            <a:schemeClr val="accent4"/>
-          </a:solidFill>
-          <a:ln/>
-        </p:spPr>
-        <p:txBody>
-          <a:bodyPr wrap="square" lIns="0" tIns="0" rIns="0" bIns="0" rtlCol="0" anchor="ctr"/>
-          <a:lstStyle/>
-          <a:p>
-            <a:pPr algn="ctr" indent="0" marL="0">
-              <a:buNone/>
-            </a:pPr>
-            <a:r>
-              <a:rPr lang="en-US" sz="1400" spc="150" kern="0" dirty="0">
-                <a:solidFill>
-                  <a:schemeClr val="tx1"/>
-                </a:solidFill>
-                <a:latin typeface="Clash Display Semibold" pitchFamily="34" charset="0"/>
-                <a:ea typeface="Clash Display Semibold" pitchFamily="34" charset="-122"/>
-                <a:cs typeface="Clash Display Semibold" pitchFamily="34" charset="-120"/>
-              </a:rPr>
-              <a:t>BUILT: IMPLEMENTATION CHECK ONLY</a:t>
-            </a:r>
-            <a:endParaRPr lang="en-US" sz="1400" dirty="0"/>
-          </a:p>
-        </p:txBody>
-      </p:sp>
-      <p:sp>
-        <p:nvSpPr>
-          <p:cNvPr id="12" name="Pill NOT RUN: PARTICIPANT TEST"/>
-          <p:cNvSpPr/>
-          <p:nvPr/>
-        </p:nvSpPr>
-        <p:spPr>
-          <a:xfrm>
-            <a:off x="6629400" y="4754880"/>
-            <a:ext cx="3383280" cy="329184"/>
-          </a:xfrm>
-          <a:prstGeom prst="roundRect">
-            <a:avLst>
-              <a:gd name="adj" fmla="val 50000"/>
-            </a:avLst>
-          </a:prstGeom>
-          <a:solidFill>
-            <a:schemeClr val="accent4"/>
-          </a:solidFill>
-          <a:ln/>
-        </p:spPr>
-        <p:txBody>
-          <a:bodyPr wrap="square" lIns="0" tIns="0" rIns="0" bIns="0" rtlCol="0" anchor="ctr"/>
-          <a:lstStyle/>
-          <a:p>
-            <a:pPr algn="ctr" indent="0" marL="0">
-              <a:buNone/>
-            </a:pPr>
-            <a:r>
-              <a:rPr lang="en-US" sz="1400" spc="150" kern="0" dirty="0">
-                <a:solidFill>
-                  <a:schemeClr val="tx1"/>
-                </a:solidFill>
-                <a:latin typeface="Clash Display Semibold" pitchFamily="34" charset="0"/>
-                <a:ea typeface="Clash Display Semibold" pitchFamily="34" charset="-122"/>
-                <a:cs typeface="Clash Display Semibold" pitchFamily="34" charset="-120"/>
-              </a:rPr>
-              <a:t>NOT RUN: PARTICIPANT TEST</a:t>
-            </a:r>
-            <a:endParaRPr lang="en-US" sz="1400" dirty="0"/>
-          </a:p>
-        </p:txBody>
-      </p:sp>
-      <p:sp>
-        <p:nvSpPr>
-          <p:cNvPr id="13" name="Text 11"/>
-          <p:cNvSpPr txBox="1"/>
-          <p:nvPr/>
-        </p:nvSpPr>
-        <p:spPr>
-          <a:xfrm>
-            <a:off x="6629400" y="5212080"/>
-            <a:ext cx="4663440" cy="640080"/>
-          </a:xfrm>
-          <a:prstGeom prst="rect">
-            <a:avLst/>
-          </a:prstGeom>
-          <a:noFill/>
-          <a:ln/>
-        </p:spPr>
-        <p:txBody>
-          <a:bodyPr wrap="square" lIns="0" tIns="0" rIns="0" bIns="0" rtlCol="0" anchor="t"/>
-          <a:lstStyle/>
-          <a:p>
-            <a:pPr indent="0" marL="0">
-              <a:buNone/>
-            </a:pPr>
-            <a:r>
-              <a:rPr lang="en-US" sz="1600" dirty="0">
-                <a:solidFill>
-                  <a:srgbClr val="B3B3B3"/>
-                </a:solidFill>
-                <a:latin typeface="PP Mori" pitchFamily="34" charset="0"/>
-                <a:ea typeface="PP Mori" pitchFamily="34" charset="-122"/>
-                <a:cs typeface="PP Mori" pitchFamily="34" charset="-120"/>
-              </a:rPr>
-              <a:t>Next: examine a recent real decision with a practitioner.</a:t>
-            </a:r>
-            <a:endParaRPr lang="en-US" sz="1600" dirty="0"/>
+            <a:endParaRPr lang="en-US" sz="3400" dirty="0"/>
           </a:p>
         </p:txBody>
       </p:sp>

</xml_diff>

<commit_message>
Correct the tiny-acts principle: tiniest act that returns the brutal truth
Tiny alone is not enough. The winner is the tiniest act of discovery that
returns the most brutal truth, or enough signal to pivot, punt or pursue.
Updated deck, notebook docs, demo script, SHOWRUN and prototyping skill,
and regenerated prompts and the PDF backup.

Co-Authored-By: Claude Sonnet 5.5 <noreply@anthropic.com>
</commit_message>
<xml_diff>
--- a/slides/Build-the-Right-Thing.pptx
+++ b/slides/Build-the-Right-Thing.pptx
@@ -1755,7 +1755,7 @@
           <a:p>
             <a:r>
               <a:rPr lang="en-US" dirty="0"/>
-              <a:t>The question is the smallest, cheapest test that surfaces the most brutal truth. Compare a conversation, a storyboard or wireframe test, an interaction, and a build. Recommend the tiniest act of discovery that can answer it. Status, if asked: prototypes built in advance are implementation evidence only. The participant test is NOT RUN until a person actually runs it. If you did not build one, say NOT BUILT.</a:t>
+              <a:t>The question is the smallest, cheapest test that surfaces the most brutal truth. Compare a conversation, a storyboard or wireframe test, an interaction, and a build. Recommend the tiniest act of discovery that returns the most brutal truth, or enough signal to pivot, punt or pursue. Tiny alone is not enough: teams usually overbuild their experiments instead of running tiny acts of discovery. Status, if asked: prototypes built in advance are implementation evidence only. The participant test is NOT RUN until a person actually runs it. If you did not build one, say NOT BUILT.</a:t>
             </a:r>
             <a:endParaRPr lang="en-US" dirty="0"/>
           </a:p>
@@ -1843,7 +1843,7 @@
           <a:p>
             <a:r>
               <a:rPr lang="en-US" dirty="0"/>
-              <a:t>Jeff Patton: the most expensive way to test your idea is to build production quality software. A polished prototype is not stronger evidence. It may be a more expensive rendering of weak assumptions. Lo-fi wins. Quote source: https://jpattonassociates.com/dual-track-development/ (Jeff Patton, Dual Track Development is not Duel Track, 2017). Cost labels on this ladder are illustrative, not universal; choose the lowest fidelity that can expose the risk.</a:t>
+              <a:t>Jeff Patton: the most expensive way to test your idea is to build production quality software. A polished prototype is not stronger evidence. It may be a more expensive rendering of weak assumptions. Lo-fi wins only if it still tells the truth. Quote source: https://jpattonassociates.com/dual-track-development/ (Jeff Patton, Dual Track Development is not Duel Track, 2017). Cost labels on this ladder are illustrative, not universal; choose the lowest fidelity that can expose the risk.</a:t>
             </a:r>
             <a:endParaRPr lang="en-US" dirty="0"/>
           </a:p>
@@ -10635,7 +10635,7 @@
                 <a:ea typeface="PP Mori" pitchFamily="34" charset="-122"/>
                 <a:cs typeface="PP Mori" pitchFamily="34" charset="-120"/>
               </a:rPr>
-              <a:t>The tiniest act of discovery wins.</a:t>
+              <a:t>The tiniest act that gives enough signal to pivot, punt or pursue.</a:t>
             </a:r>
             <a:endParaRPr lang="en-US" sz="1600" dirty="0"/>
           </a:p>
@@ -10772,7 +10772,24 @@
                 <a:ea typeface="Clash Grotesk Medium" pitchFamily="34" charset="-122"/>
                 <a:cs typeface="Clash Grotesk Medium" pitchFamily="34" charset="-120"/>
               </a:rPr>
-              <a:t>TINIEST ACT WINS</a:t>
+              <a:t>TINIEST ACT THAT</a:t>
+            </a:r>
+            <a:endParaRPr lang="en-US" sz="3400" dirty="0"/>
+          </a:p>
+          <a:p>
+            <a:pPr algn="ctr" indent="0" marL="0">
+              <a:buNone/>
+            </a:pPr>
+            <a:r>
+              <a:rPr lang="en-US" sz="3400" dirty="0">
+                <a:solidFill>
+                  <a:srgbClr val="00C765"/>
+                </a:solidFill>
+                <a:latin typeface="Clash Grotesk Medium" pitchFamily="34" charset="0"/>
+                <a:ea typeface="Clash Grotesk Medium" pitchFamily="34" charset="-122"/>
+                <a:cs typeface="Clash Grotesk Medium" pitchFamily="34" charset="-120"/>
+              </a:rPr>
+              <a:t>TELLS THE TRUTH</a:t>
             </a:r>
             <a:endParaRPr lang="en-US" sz="3400" dirty="0"/>
           </a:p>
@@ -11393,8 +11410,8 @@
         </p:nvSpPr>
         <p:spPr>
           <a:xfrm>
-            <a:off x="7498080" y="731520"/>
-            <a:ext cx="4114800" cy="548640"/>
+            <a:off x="6583680" y="731520"/>
+            <a:ext cx="5029200" cy="548640"/>
           </a:xfrm>
           <a:prstGeom prst="rect">
             <a:avLst/>
@@ -11410,7 +11427,7 @@
               <a:buNone/>
             </a:pPr>
             <a:r>
-              <a:rPr lang="en-US" sz="3200" dirty="0">
+              <a:rPr lang="en-US" sz="3000" dirty="0">
                 <a:solidFill>
                   <a:schemeClr val="accent1"/>
                 </a:solidFill>
@@ -11418,9 +11435,9 @@
                 <a:ea typeface="Clash Grotesk Medium" pitchFamily="34" charset="-122"/>
                 <a:cs typeface="Clash Grotesk Medium" pitchFamily="34" charset="-120"/>
               </a:rPr>
-              <a:t>Lo-fi wins.</a:t>
-            </a:r>
-            <a:endParaRPr lang="en-US" sz="3200" dirty="0"/>
+              <a:t>Lo-fi, if it tells the truth.</a:t>
+            </a:r>
+            <a:endParaRPr lang="en-US" sz="3000" dirty="0"/>
           </a:p>
         </p:txBody>
       </p:sp>

</xml_diff>

<commit_message>
Prototyping slide stamp: JUST ENOUGH SIGNAL
Co-Authored-By: Claude Sonnet 5.5 <noreply@anthropic.com>
</commit_message>
<xml_diff>
--- a/slides/Build-the-Right-Thing.pptx
+++ b/slides/Build-the-Right-Thing.pptx
@@ -10736,7 +10736,7 @@
       </p:sp>
       <p:sp>
         <p:nvSpPr>
-          <p:cNvPr id="10" name="Tiniest act wins stamp"/>
+          <p:cNvPr id="10" name="Just enough signal stamp"/>
           <p:cNvSpPr/>
           <p:nvPr/>
         </p:nvSpPr>
@@ -10764,7 +10764,7 @@
               <a:buNone/>
             </a:pPr>
             <a:r>
-              <a:rPr lang="en-US" sz="3400" dirty="0">
+              <a:rPr lang="en-US" sz="4000" dirty="0">
                 <a:solidFill>
                   <a:srgbClr val="00C765"/>
                 </a:solidFill>
@@ -10772,16 +10772,16 @@
                 <a:ea typeface="Clash Grotesk Medium" pitchFamily="34" charset="-122"/>
                 <a:cs typeface="Clash Grotesk Medium" pitchFamily="34" charset="-120"/>
               </a:rPr>
-              <a:t>TINIEST ACT THAT</a:t>
-            </a:r>
-            <a:endParaRPr lang="en-US" sz="3400" dirty="0"/>
+              <a:t>JUST ENOUGH</a:t>
+            </a:r>
+            <a:endParaRPr lang="en-US" sz="4000" dirty="0"/>
           </a:p>
           <a:p>
             <a:pPr algn="ctr" indent="0" marL="0">
               <a:buNone/>
             </a:pPr>
             <a:r>
-              <a:rPr lang="en-US" sz="3400" dirty="0">
+              <a:rPr lang="en-US" sz="4000" dirty="0">
                 <a:solidFill>
                   <a:srgbClr val="00C765"/>
                 </a:solidFill>
@@ -10789,9 +10789,9 @@
                 <a:ea typeface="Clash Grotesk Medium" pitchFamily="34" charset="-122"/>
                 <a:cs typeface="Clash Grotesk Medium" pitchFamily="34" charset="-120"/>
               </a:rPr>
-              <a:t>TELLS THE TRUTH</a:t>
-            </a:r>
-            <a:endParaRPr lang="en-US" sz="3400" dirty="0"/>
+              <a:t>SIGNAL</a:t>
+            </a:r>
+            <a:endParaRPr lang="en-US" sz="4000" dirty="0"/>
           </a:p>
         </p:txBody>
       </p:sp>

</xml_diff>